<commit_message>
docs: second pitch pass (signals/OB-only framing, no em-dashes); rename OBCO->WCO, OB_Vend->LCO repo-wide
</commit_message>
<xml_diff>
--- a/Board pitch/Owned_Brands_Board_Deck.pptx
+++ b/Board pitch/Owned_Brands_Board_Deck.pptx
@@ -1632,7 +1632,7 @@
                 <a:ea typeface="Calibri" pitchFamily="34" charset="-122"/>
                 <a:cs typeface="Calibri" pitchFamily="34" charset="-120"/>
               </a:rPr>
-              <a:t>A read-only, vendor-side intelligence and activity platform inside WCO — it surfaces the signals and tracks our engagement, so the Owned Brands team shows up at the right time with the right pitch.</a:t>
+              <a:t>A read-only, vendor-side intelligence and activity platform inside WCO. It surfaces the signals and tracks our engagement, so the Owned Brands team shows up at the right time with the right pitch.</a:t>
             </a:r>
             <a:endParaRPr lang="en-US" sz="1700" dirty="0"/>
           </a:p>
@@ -1782,7 +1782,7 @@
                 <a:ea typeface="Consolas" pitchFamily="34" charset="-122"/>
                 <a:cs typeface="Consolas" pitchFamily="34" charset="-120"/>
               </a:rPr>
-              <a:t>owned brands grow</a:t>
+              <a:t>growth</a:t>
             </a:r>
             <a:endParaRPr lang="en-US" sz="1300" dirty="0"/>
           </a:p>
@@ -1821,7 +1821,7 @@
                 <a:ea typeface="Calibri" pitchFamily="34" charset="-122"/>
                 <a:cs typeface="Calibri" pitchFamily="34" charset="-120"/>
               </a:rPr>
-              <a:t>Jeff Goodman — Director, Sales, Owned Brands   ·   June 19, 2026   ·   Status: Discovery / prototype</a:t>
+              <a:t>Jeff Goodman   ·   Director, Sales, Owned Brands   ·   June 19, 2026   ·   Status: Discovery / prototype</a:t>
             </a:r>
             <a:endParaRPr lang="en-US" sz="1100" dirty="0"/>
           </a:p>
@@ -1892,7 +1892,7 @@
                 <a:ea typeface="Consolas" pitchFamily="34" charset="-122"/>
                 <a:cs typeface="Consolas" pitchFamily="34" charset="-120"/>
               </a:rPr>
-              <a:t>WHO WE ARE — AND WHAT’S MISSING</a:t>
+              <a:t>WHO WE ARE, AND WHAT’S MISSING</a:t>
             </a:r>
             <a:endParaRPr lang="en-US" sz="1100" dirty="0"/>
           </a:p>
@@ -2101,7 +2101,7 @@
                 <a:ea typeface="Calibri" pitchFamily="34" charset="-122"/>
                 <a:cs typeface="Calibri" pitchFamily="34" charset="-120"/>
               </a:rPr>
-              <a:t>The Owned Brands team is WCO’s owned-brands vendor team — our job is to call on WCO sellers and select customers and help them win.</a:t>
+              <a:t>The Owned Brands team is WCO’s owned-brands vendor team. Our job is to call on WCO sellers and select customers and help them win.</a:t>
             </a:r>
             <a:endParaRPr lang="en-US" sz="1400" dirty="0"/>
           </a:p>
@@ -2393,7 +2393,7 @@
                 <a:ea typeface="Trebuchet MS" pitchFamily="34" charset="-122"/>
                 <a:cs typeface="Trebuchet MS" pitchFamily="34" charset="-120"/>
               </a:rPr>
-              <a:t>It lives in spreadsheets</a:t>
+              <a:t>We have no tools of our own</a:t>
             </a:r>
             <a:endParaRPr lang="en-US" sz="1600" dirty="0"/>
           </a:p>
@@ -2435,7 +2435,7 @@
                 <a:ea typeface="Calibri" pitchFamily="34" charset="-122"/>
                 <a:cs typeface="Calibri" pitchFamily="34" charset="-120"/>
               </a:rPr>
-              <a:t>WCO’s distributor systems were never built for the vendor lens, so the work — and the signal — scatters across disconnected files.</a:t>
+              <a:t>WCO’s distributor systems weren’t built for the vendor lens. OB-specific tools would lift win rate and margin organization-wide.</a:t>
             </a:r>
             <a:endParaRPr lang="en-US" sz="1400" dirty="0"/>
           </a:p>
@@ -2527,7 +2527,7 @@
                 <a:ea typeface="Calibri" pitchFamily="34" charset="-122"/>
                 <a:cs typeface="Calibri" pitchFamily="34" charset="-120"/>
               </a:rPr>
-              <a:t>   ·   Confidential — Internal   ·   2 / 8</a:t>
+              <a:t>   ·   Confidential / Internal   ·   2 / 8</a:t>
             </a:r>
             <a:endParaRPr lang="en-US" sz="900" dirty="0"/>
           </a:p>
@@ -2733,7 +2733,7 @@
                 <a:ea typeface="Trebuchet MS" pitchFamily="34" charset="-122"/>
                 <a:cs typeface="Trebuchet MS" pitchFamily="34" charset="-120"/>
               </a:rPr>
-              <a:t>Distributor lens — CORE &amp; USD</a:t>
+              <a:t>Distributor lens: CORE &amp; USD</a:t>
             </a:r>
             <a:endParaRPr lang="en-US" sz="1600" dirty="0"/>
           </a:p>
@@ -2890,7 +2890,7 @@
                 <a:ea typeface="Trebuchet MS" pitchFamily="34" charset="-122"/>
                 <a:cs typeface="Trebuchet MS" pitchFamily="34" charset="-120"/>
               </a:rPr>
-              <a:t>Vendor lens — what Owned Brands needs</a:t>
+              <a:t>Vendor lens: what Owned Brands needs</a:t>
             </a:r>
             <a:endParaRPr lang="en-US" sz="1600" dirty="0"/>
           </a:p>
@@ -3008,7 +3008,7 @@
                 <a:ea typeface="Calibri" pitchFamily="34" charset="-122"/>
                 <a:cs typeface="Calibri" pitchFamily="34" charset="-120"/>
               </a:rPr>
-              <a:t>Opportunities, quotes, and engagements tracked</a:t>
+              <a:t>Engagement with WCO sellers (our customer; not in USD)</a:t>
             </a:r>
             <a:endParaRPr lang="en-US" sz="1400" dirty="0"/>
           </a:p>
@@ -3047,7 +3047,7 @@
                 <a:ea typeface="Calibri" pitchFamily="34" charset="-122"/>
                 <a:cs typeface="Calibri" pitchFamily="34" charset="-120"/>
               </a:rPr>
-              <a:t>Without the vendor lens, the signal lives in disconnected spreadsheets — invisible to leadership and impossible to scale.</a:t>
+              <a:t>Without the vendor lens, the signal lives in disconnected spreadsheets, invisible to leadership and impossible to scale.</a:t>
             </a:r>
             <a:endParaRPr lang="en-US" sz="1500" dirty="0"/>
           </a:p>
@@ -3100,7 +3100,7 @@
                 <a:ea typeface="Calibri" pitchFamily="34" charset="-122"/>
                 <a:cs typeface="Calibri" pitchFamily="34" charset="-120"/>
               </a:rPr>
-              <a:t>   ·   Confidential — Internal   ·   3 / 8</a:t>
+              <a:t>   ·   Confidential / Internal   ·   3 / 8</a:t>
             </a:r>
             <a:endParaRPr lang="en-US" sz="900" dirty="0"/>
           </a:p>
@@ -3171,7 +3171,7 @@
                 <a:ea typeface="Consolas" pitchFamily="34" charset="-122"/>
                 <a:cs typeface="Consolas" pitchFamily="34" charset="-120"/>
               </a:rPr>
-              <a:t>THE ENGINE — OUR NORTH STAR</a:t>
+              <a:t>THE ENGINE, OUR NORTH STAR</a:t>
             </a:r>
             <a:endParaRPr lang="en-US" sz="1100" dirty="0"/>
           </a:p>
@@ -3380,7 +3380,7 @@
                 <a:ea typeface="Calibri" pitchFamily="34" charset="-122"/>
                 <a:cs typeface="Calibri" pitchFamily="34" charset="-120"/>
               </a:rPr>
-              <a:t>Signal in the governed data — deal at risk or margin under pressure</a:t>
+              <a:t>Signal in the governed data: a deal at risk or margin under pressure</a:t>
             </a:r>
             <a:endParaRPr lang="en-US" sz="1300" dirty="0"/>
           </a:p>
@@ -4040,7 +4040,7 @@
                 <a:ea typeface="Calibri" pitchFamily="34" charset="-122"/>
                 <a:cs typeface="Calibri" pitchFamily="34" charset="-120"/>
               </a:rPr>
-              <a:t>The SKU is the spine </a:t>
+              <a:t>The SKU is the spine. </a:t>
             </a:r>
             <a:pPr indent="0" marL="0">
               <a:lnSpc>
@@ -4057,7 +4057,7 @@
                 <a:ea typeface="Calibri" pitchFamily="34" charset="-122"/>
                 <a:cs typeface="Calibri" pitchFamily="34" charset="-120"/>
               </a:rPr>
-              <a:t>— one detail view unifies sales, stock, opportunities, crosses, and activity. Two tiers run the model: the WCO seller channel (push) and WCO customers (pull).</a:t>
+              <a:t>One detail view unifies sales, stock, opportunities, crosses, and activity. Two tiers run the model: the WCO seller channel (push) and WCO customers (pull).</a:t>
             </a:r>
             <a:endParaRPr lang="en-US" sz="1500" dirty="0"/>
           </a:p>
@@ -4110,7 +4110,7 @@
                 <a:ea typeface="Calibri" pitchFamily="34" charset="-122"/>
                 <a:cs typeface="Calibri" pitchFamily="34" charset="-120"/>
               </a:rPr>
-              <a:t>   ·   Confidential — Internal   ·   4 / 8</a:t>
+              <a:t>   ·   Confidential / Internal   ·   4 / 8</a:t>
             </a:r>
             <a:endParaRPr lang="en-US" sz="900" dirty="0"/>
           </a:p>
@@ -4223,7 +4223,7 @@
                 <a:ea typeface="Trebuchet MS" pitchFamily="34" charset="-122"/>
                 <a:cs typeface="Trebuchet MS" pitchFamily="34" charset="-120"/>
               </a:rPr>
-              <a:t>A vendor-side platform and CRM — already prototyped</a:t>
+              <a:t>A vendor-side platform and CRM, already prototyped</a:t>
             </a:r>
             <a:endParaRPr lang="en-US" sz="2700" dirty="0"/>
           </a:p>
@@ -4390,7 +4390,7 @@
                 <a:ea typeface="Calibri" pitchFamily="34" charset="-122"/>
                 <a:cs typeface="Calibri" pitchFamily="34" charset="-120"/>
               </a:rPr>
-              <a:t>Competitive product → owned-brand part mapping; living, searchable.</a:t>
+              <a:t>Competitive product → owned-brand mapping. OB enablement, not org-wide access.</a:t>
             </a:r>
             <a:endParaRPr lang="en-US" sz="1250" dirty="0"/>
           </a:p>
@@ -4557,7 +4557,7 @@
                 <a:ea typeface="Calibri" pitchFamily="34" charset="-122"/>
                 <a:cs typeface="Calibri" pitchFamily="34" charset="-120"/>
               </a:rPr>
-              <a:t>Where to show up — deals at risk, margin under pressure, stock signal.</a:t>
+              <a:t>Where to show up: deals at risk, margin under pressure, stock signal.</a:t>
             </a:r>
             <a:endParaRPr lang="en-US" sz="1250" dirty="0"/>
           </a:p>
@@ -4724,7 +4724,7 @@
                 <a:ea typeface="Calibri" pitchFamily="34" charset="-122"/>
                 <a:cs typeface="Calibri" pitchFamily="34" charset="-120"/>
               </a:rPr>
-              <a:t>OB engagement with WCO sellers and customers — quotes, calls, demos.</a:t>
+              <a:t>OB-generated opportunities; engagement with WCO sellers, our customer (not in USD).</a:t>
             </a:r>
             <a:endParaRPr lang="en-US" sz="1250" dirty="0"/>
           </a:p>
@@ -4891,7 +4891,7 @@
                 <a:ea typeface="Calibri" pitchFamily="34" charset="-122"/>
                 <a:cs typeface="Calibri" pitchFamily="34" charset="-120"/>
               </a:rPr>
-              <a:t>A note → structured records; datasheet cross-extraction.</a:t>
+              <a:t>A note → records; opportunity-loss and product-development signals.</a:t>
             </a:r>
             <a:endParaRPr lang="en-US" sz="1250" dirty="0"/>
           </a:p>
@@ -5264,7 +5264,7 @@
                 <a:ea typeface="Calibri" pitchFamily="34" charset="-122"/>
                 <a:cs typeface="Calibri" pitchFamily="34" charset="-120"/>
               </a:rPr>
-              <a:t>A working two-persona prototype (Leadership + Sales Team) already exists — this is proven UX, not a concept.</a:t>
+              <a:t>A working two-persona prototype (Leadership + Sales Team) already exists: proven UX, not a concept.</a:t>
             </a:r>
             <a:endParaRPr lang="en-US" sz="1400" dirty="0"/>
           </a:p>
@@ -5317,7 +5317,7 @@
                 <a:ea typeface="Calibri" pitchFamily="34" charset="-122"/>
                 <a:cs typeface="Calibri" pitchFamily="34" charset="-120"/>
               </a:rPr>
-              <a:t>   ·   Confidential — Internal   ·   5 / 8</a:t>
+              <a:t>   ·   Confidential / Internal   ·   5 / 8</a:t>
             </a:r>
             <a:endParaRPr lang="en-US" sz="900" dirty="0"/>
           </a:p>
@@ -5430,7 +5430,7 @@
                 <a:ea typeface="Trebuchet MS" pitchFamily="34" charset="-122"/>
                 <a:cs typeface="Trebuchet MS" pitchFamily="34" charset="-120"/>
               </a:rPr>
-              <a:t>Read-only and in-tenant — zero risk to CORE or USD</a:t>
+              <a:t>Read-only and in-tenant: zero risk to CORE or USD</a:t>
             </a:r>
             <a:endParaRPr lang="en-US" sz="2700" dirty="0"/>
           </a:p>
@@ -5510,8 +5510,8 @@
         </p:nvSpPr>
         <p:spPr>
           <a:xfrm>
-            <a:off x="822960" y="2834640"/>
-            <a:ext cx="4815688" cy="2194560"/>
+            <a:off x="822960" y="2788920"/>
+            <a:ext cx="4815688" cy="2286000"/>
           </a:xfrm>
           <a:prstGeom prst="rect">
             <a:avLst/>
@@ -5525,10 +5525,10 @@
           <a:p>
             <a:pPr marL="342900" indent="-342900">
               <a:lnSpc>
-                <a:spcPct val="115000"/>
+                <a:spcPct val="112000"/>
               </a:lnSpc>
               <a:spcAft>
-                <a:spcPts val="800"/>
+                <a:spcPts val="600"/>
               </a:spcAft>
               <a:buSzPct val="100000"/>
               <a:buChar char="✕"/>
@@ -5549,10 +5549,10 @@
           <a:p>
             <a:pPr marL="342900" indent="-342900">
               <a:lnSpc>
-                <a:spcPct val="115000"/>
+                <a:spcPct val="112000"/>
               </a:lnSpc>
               <a:spcAft>
-                <a:spcPts val="800"/>
+                <a:spcPts val="600"/>
               </a:spcAft>
               <a:buSzPct val="100000"/>
               <a:buChar char="✕"/>
@@ -5573,10 +5573,10 @@
           <a:p>
             <a:pPr marL="342900" indent="-342900">
               <a:lnSpc>
-                <a:spcPct val="115000"/>
+                <a:spcPct val="112000"/>
               </a:lnSpc>
               <a:spcAft>
-                <a:spcPts val="800"/>
+                <a:spcPts val="600"/>
               </a:spcAft>
               <a:buSzPct val="100000"/>
               <a:buChar char="✕"/>
@@ -5597,10 +5597,34 @@
           <a:p>
             <a:pPr marL="342900" indent="-342900">
               <a:lnSpc>
-                <a:spcPct val="115000"/>
+                <a:spcPct val="112000"/>
               </a:lnSpc>
               <a:spcAft>
-                <a:spcPts val="800"/>
+                <a:spcPts val="600"/>
+              </a:spcAft>
+              <a:buSzPct val="100000"/>
+              <a:buChar char="✕"/>
+            </a:pPr>
+            <a:r>
+              <a:rPr lang="en-US" sz="1400" dirty="0">
+                <a:solidFill>
+                  <a:srgbClr val="14241C"/>
+                </a:solidFill>
+                <a:latin typeface="Calibri" pitchFamily="34" charset="0"/>
+                <a:ea typeface="Calibri" pitchFamily="34" charset="-122"/>
+                <a:cs typeface="Calibri" pitchFamily="34" charset="-120"/>
+              </a:rPr>
+              <a:t>No access outside the OB sales team</a:t>
+            </a:r>
+            <a:endParaRPr lang="en-US" sz="1400" dirty="0"/>
+          </a:p>
+          <a:p>
+            <a:pPr marL="342900" indent="-342900">
+              <a:lnSpc>
+                <a:spcPct val="112000"/>
+              </a:lnSpc>
+              <a:spcAft>
+                <a:spcPts val="600"/>
               </a:spcAft>
               <a:buSzPct val="100000"/>
               <a:buChar char="✕"/>
@@ -5774,7 +5798,7 @@
                 <a:ea typeface="Calibri" pitchFamily="34" charset="-122"/>
                 <a:cs typeface="Calibri" pitchFamily="34" charset="-120"/>
               </a:rPr>
-              <a:t>Embedded certified Power BI — no dataset duplication</a:t>
+              <a:t>Embedded certified Power BI, no dataset duplication</a:t>
             </a:r>
             <a:endParaRPr lang="en-US" sz="1400" dirty="0"/>
           </a:p>
@@ -5890,7 +5914,7 @@
                 <a:ea typeface="Calibri" pitchFamily="34" charset="-122"/>
                 <a:cs typeface="Calibri" pitchFamily="34" charset="-120"/>
               </a:rPr>
-              <a:t>   ·   Confidential — Internal   ·   6 / 8</a:t>
+              <a:t>   ·   Confidential / Internal   ·   6 / 8</a:t>
             </a:r>
             <a:endParaRPr lang="en-US" sz="900" dirty="0"/>
           </a:p>
@@ -6446,7 +6470,7 @@
                 <a:ea typeface="Calibri" pitchFamily="34" charset="-122"/>
                 <a:cs typeface="Calibri" pitchFamily="34" charset="-120"/>
               </a:rPr>
-              <a:t>Azure production — data layer, app DB, identity, Power BI</a:t>
+              <a:t>Azure production: data layer, app DB, identity, Power BI</a:t>
             </a:r>
             <a:endParaRPr lang="en-US" sz="1250" dirty="0"/>
           </a:p>
@@ -6818,7 +6842,7 @@
                 <a:ea typeface="Calibri" pitchFamily="34" charset="-122"/>
                 <a:cs typeface="Calibri" pitchFamily="34" charset="-120"/>
               </a:rPr>
-              <a:t>   ·   Confidential — Internal   ·   7 / 8</a:t>
+              <a:t>   ·   Confidential / Internal   ·   7 / 8</a:t>
             </a:r>
             <a:endParaRPr lang="en-US" sz="900" dirty="0"/>
           </a:p>
@@ -7098,7 +7122,7 @@
                 <a:ea typeface="Calibri" pitchFamily="34" charset="-122"/>
                 <a:cs typeface="Calibri" pitchFamily="34" charset="-120"/>
               </a:rPr>
-              <a:t>Governed WCO sales data incl. margin/cost — via certified datasets, Power BI, or the API layer. Defined user group: the Owned Brands sales team.</a:t>
+              <a:t>Governed WCO sales data incl. margin/cost, via certified datasets, Power BI, or the API layer. User group: the Owned Brands sales team only, no access outside OB.</a:t>
             </a:r>
             <a:endParaRPr lang="en-US" sz="1300" dirty="0"/>
           </a:p>
@@ -7432,7 +7456,7 @@
                 <a:ea typeface="Calibri" pitchFamily="34" charset="-122"/>
                 <a:cs typeface="Calibri" pitchFamily="34" charset="-120"/>
               </a:rPr>
-              <a:t>Named contacts from Data Office, BI Governance, Cloud Engineering, and IT Security — plus confirmation of the access-request workflow and margin/cost classification.</a:t>
+              <a:t>Named contacts from Data Office, BI Governance, Cloud Engineering, and IT Security, plus confirmation of the access-request workflow and margin/cost classification.</a:t>
             </a:r>
             <a:endParaRPr lang="en-US" sz="1300" dirty="0"/>
           </a:p>
@@ -7485,7 +7509,7 @@
                 <a:ea typeface="Calibri" pitchFamily="34" charset="-122"/>
                 <a:cs typeface="Calibri" pitchFamily="34" charset="-120"/>
               </a:rPr>
-              <a:t>writes to CORE/USD, direct DB connectivity, data duplication, or any egress.</a:t>
+              <a:t>writes to CORE/USD, direct DB connectivity, data duplication, access outside OB, or any egress.</a:t>
             </a:r>
             <a:endParaRPr lang="en-US" sz="1300" dirty="0"/>
           </a:p>
@@ -7524,7 +7548,7 @@
                 <a:ea typeface="Trebuchet MS" pitchFamily="34" charset="-122"/>
                 <a:cs typeface="Trebuchet MS" pitchFamily="34" charset="-120"/>
               </a:rPr>
-              <a:t>Approve these and the Owned Brands team can finally see the signals — and act on them.</a:t>
+              <a:t>Approve these and the Owned Brands team can finally see the signals and act on them.</a:t>
             </a:r>
             <a:endParaRPr lang="en-US" sz="1500" dirty="0"/>
           </a:p>

</xml_diff>

<commit_message>
docs: add dashboard to one-pager; propagate page-1 edits to deck and page 2
</commit_message>
<xml_diff>
--- a/Board pitch/Owned_Brands_Board_Deck.pptx
+++ b/Board pitch/Owned_Brands_Board_Deck.pptx
@@ -2279,7 +2279,7 @@
                 <a:ea typeface="Calibri" pitchFamily="34" charset="-122"/>
                 <a:cs typeface="Calibri" pitchFamily="34" charset="-120"/>
               </a:rPr>
-              <a:t>Governed WCO sales data incl. margin/cost, via certified datasets, Power BI, or the API layer. User group: the Owned Brands sales team only, no access outside OB.</a:t>
+              <a:t>Governed WCO sales data incl. margin/cost, via certified datasets, Power BI, or the API layer. User group: the Owned Brands sales team only. No access provided outside of OB.</a:t>
             </a:r>
             <a:endParaRPr lang="en-US" sz="1300" dirty="0"/>
           </a:p>
@@ -3319,7 +3319,7 @@
                 <a:ea typeface="Calibri" pitchFamily="34" charset="-122"/>
                 <a:cs typeface="Calibri" pitchFamily="34" charset="-120"/>
               </a:rPr>
-              <a:t>WCO’s systems (CORE, our ERP; USD, our CRM) weren’t built for the vendor lens. OB-specific tools would lift win rate and margin org-wide.</a:t>
+              <a:t>WCO’s systems (CORE, USD) weren’t built for the vendor lens. OB-specific tools would lift win rate and margin org-wide.</a:t>
             </a:r>
             <a:endParaRPr lang="en-US" sz="1400" dirty="0"/>
           </a:p>
@@ -4504,7 +4504,7 @@
                 <a:ea typeface="Calibri" pitchFamily="34" charset="-122"/>
                 <a:cs typeface="Calibri" pitchFamily="34" charset="-120"/>
               </a:rPr>
-              <a:t>The right WCO seller or customer, with the cross and the context</a:t>
+              <a:t>The right WCO seller or customer, at the right time, with the cross and context</a:t>
             </a:r>
             <a:endParaRPr lang="en-US" sz="1300" dirty="0"/>
           </a:p>
@@ -7083,7 +7083,7 @@
                 <a:ea typeface="Calibri" pitchFamily="34" charset="-122"/>
                 <a:cs typeface="Calibri" pitchFamily="34" charset="-120"/>
               </a:rPr>
-              <a:t>, adding capability and aligning structure to the Owned Brands mandate inside WCO. The structure is in place; the tooling isn’t.</a:t>
+              <a:t>, adding capability and aligning structure to the Owned Brands mandate inside WCO. The structure is in place; the missing piece is the toolset that lets it see around corners that are blind today.</a:t>
             </a:r>
             <a:endParaRPr lang="en-US" sz="1700" dirty="0"/>
           </a:p>

</xml_diff>